<commit_message>
feat: complete DQN9 codebase, configs, paper, and scripts
- Update all ugv_dqn core modules with experiment improvements
- Add 60+ experiment and ablation config files
- Add experiment scripts and analysis tools
- Update paper manuscript, figures, and results
- Update project documentation (CLAUDE.md, README.md)
- Update .gitignore to exclude IDE, OS, and temp files
</commit_message>
<xml_diff>
--- a/paper/media/fig2.pptx
+++ b/paper/media/fig2.pptx
@@ -3056,17 +3056,9 @@
   <p:cSld>
     <p:bg>
       <p:bgPr>
-        <a:gradFill rotWithShape="1">
-          <a:gsLst>
-            <a:gs pos="0">
-              <a:srgbClr val="F6F8FC"/>
-            </a:gs>
-            <a:gs pos="100000">
-              <a:srgbClr val="E6EDF5"/>
-            </a:gs>
-          </a:gsLst>
-          <a:lin scaled="0"/>
-        </a:gradFill>
+        <a:solidFill>
+          <a:srgbClr val="FFFFFF"/>
+        </a:solidFill>
         <a:effectLst/>
       </p:bgPr>
     </p:bg>
@@ -3108,7 +3100,7 @@
               </a:avLst>
             </a:prstGeom>
             <a:solidFill>
-              <a:srgbClr val="4472C4"/>
+              <a:srgbClr val="2E86C1"/>
             </a:solidFill>
             <a:ln>
               <a:noFill/>
@@ -3206,7 +3198,7 @@
             </a:solidFill>
             <a:ln w="6350">
               <a:solidFill>
-                <a:srgbClr val="D6E4F0"/>
+                <a:srgbClr val="AED6F1"/>
               </a:solidFill>
             </a:ln>
           </p:spPr>
@@ -3286,7 +3278,7 @@
               </a:avLst>
             </a:prstGeom>
             <a:solidFill>
-              <a:srgbClr val="4472C4"/>
+              <a:srgbClr val="2C3E50"/>
             </a:solidFill>
             <a:ln>
               <a:noFill/>
@@ -3357,7 +3349,7 @@
             </a:solidFill>
             <a:ln w="9525">
               <a:solidFill>
-                <a:srgbClr val="D6E4F0"/>
+                <a:srgbClr val="85929E"/>
               </a:solidFill>
             </a:ln>
           </p:spPr>
@@ -3407,135 +3399,6 @@
             </a:prstGeom>
           </p:spPr>
         </p:pic>
-        <p:sp>
-          <p:nvSpPr>
-            <p:cNvPr id="14" name="Oval 13"/>
-            <p:cNvSpPr/>
-            <p:nvPr/>
-          </p:nvSpPr>
-          <p:spPr>
-            <a:xfrm>
-              <a:off x="3656" y="1496"/>
-              <a:ext cx="31" cy="31"/>
-            </a:xfrm>
-            <a:prstGeom prst="ellipse">
-              <a:avLst/>
-            </a:prstGeom>
-            <a:solidFill>
-              <a:srgbClr val="4472C4"/>
-            </a:solidFill>
-            <a:ln>
-              <a:noFill/>
-            </a:ln>
-          </p:spPr>
-          <p:style>
-            <a:lnRef idx="1">
-              <a:schemeClr val="accent1"/>
-            </a:lnRef>
-            <a:fillRef idx="3">
-              <a:schemeClr val="accent1"/>
-            </a:fillRef>
-            <a:effectRef idx="2">
-              <a:schemeClr val="accent1"/>
-            </a:effectRef>
-            <a:fontRef idx="minor">
-              <a:schemeClr val="lt1"/>
-            </a:fontRef>
-          </p:style>
-          <p:txBody>
-            <a:bodyPr rtlCol="0" anchor="ctr"/>
-            <a:lstStyle/>
-            <a:p>
-              <a:pPr algn="ctr"/>
-            </a:p>
-          </p:txBody>
-        </p:sp>
-        <p:sp>
-          <p:nvSpPr>
-            <p:cNvPr id="16" name="Oval 15"/>
-            <p:cNvSpPr/>
-            <p:nvPr/>
-          </p:nvSpPr>
-          <p:spPr>
-            <a:xfrm>
-              <a:off x="3656" y="3224"/>
-              <a:ext cx="31" cy="31"/>
-            </a:xfrm>
-            <a:prstGeom prst="ellipse">
-              <a:avLst/>
-            </a:prstGeom>
-            <a:solidFill>
-              <a:srgbClr val="4472C4"/>
-            </a:solidFill>
-            <a:ln>
-              <a:noFill/>
-            </a:ln>
-          </p:spPr>
-          <p:style>
-            <a:lnRef idx="1">
-              <a:schemeClr val="accent1"/>
-            </a:lnRef>
-            <a:fillRef idx="3">
-              <a:schemeClr val="accent1"/>
-            </a:fillRef>
-            <a:effectRef idx="2">
-              <a:schemeClr val="accent1"/>
-            </a:effectRef>
-            <a:fontRef idx="minor">
-              <a:schemeClr val="lt1"/>
-            </a:fontRef>
-          </p:style>
-          <p:txBody>
-            <a:bodyPr rtlCol="0" anchor="ctr"/>
-            <a:lstStyle/>
-            <a:p>
-              <a:pPr algn="ctr"/>
-            </a:p>
-          </p:txBody>
-        </p:sp>
-        <p:sp>
-          <p:nvSpPr>
-            <p:cNvPr id="18" name="Oval 17"/>
-            <p:cNvSpPr/>
-            <p:nvPr/>
-          </p:nvSpPr>
-          <p:spPr>
-            <a:xfrm>
-              <a:off x="3656" y="4952"/>
-              <a:ext cx="31" cy="31"/>
-            </a:xfrm>
-            <a:prstGeom prst="ellipse">
-              <a:avLst/>
-            </a:prstGeom>
-            <a:solidFill>
-              <a:srgbClr val="4472C4"/>
-            </a:solidFill>
-            <a:ln>
-              <a:noFill/>
-            </a:ln>
-          </p:spPr>
-          <p:style>
-            <a:lnRef idx="1">
-              <a:schemeClr val="accent1"/>
-            </a:lnRef>
-            <a:fillRef idx="3">
-              <a:schemeClr val="accent1"/>
-            </a:fillRef>
-            <a:effectRef idx="2">
-              <a:schemeClr val="accent1"/>
-            </a:effectRef>
-            <a:fontRef idx="minor">
-              <a:schemeClr val="lt1"/>
-            </a:fontRef>
-          </p:style>
-          <p:txBody>
-            <a:bodyPr rtlCol="0" anchor="ctr"/>
-            <a:lstStyle/>
-            <a:p>
-              <a:pPr algn="ctr"/>
-            </a:p>
-          </p:txBody>
-        </p:sp>
       </p:grpSp>
       <p:grpSp>
         <p:nvGrpSpPr>
@@ -3582,7 +3445,7 @@
                 </a:avLst>
               </a:prstGeom>
               <a:solidFill>
-                <a:srgbClr val="4472C4"/>
+                <a:srgbClr val="C0392B"/>
               </a:solidFill>
               <a:ln>
                 <a:noFill/>
@@ -3639,7 +3502,7 @@
                     </a:solidFill>
                     <a:latin typeface="Times New Roman" panose="02020603050405020304"/>
                   </a:rPr>
-                  <a:t> LiDAR</a:t>
+                  <a:t/>
                 </a:r>
                 <a:endParaRPr sz="900" b="1">
                   <a:solidFill>
@@ -3680,7 +3543,7 @@
               </a:solidFill>
               <a:ln w="6350">
                 <a:solidFill>
-                  <a:srgbClr val="D6E4F0"/>
+                  <a:srgbClr val="F5B7B1"/>
                 </a:solidFill>
               </a:ln>
             </p:spPr>
@@ -3761,7 +3624,7 @@
               </a:avLst>
             </a:prstGeom>
             <a:solidFill>
-              <a:srgbClr val="4472C4"/>
+              <a:srgbClr val="27AE60"/>
             </a:solidFill>
             <a:ln>
               <a:noFill/>
@@ -3827,7 +3690,7 @@
                   </a:solidFill>
                   <a:latin typeface="Times New Roman" panose="02020603050405020304"/>
                 </a:rPr>
-                <a:t> LiDAR</a:t>
+                <a:t/>
               </a:r>
               <a:endParaRPr sz="900" b="1">
                 <a:solidFill>
@@ -3868,7 +3731,7 @@
             </a:solidFill>
             <a:ln w="6350">
               <a:solidFill>
-                <a:srgbClr val="D6E4F0"/>
+                <a:srgbClr val="A9DFBF"/>
               </a:solidFill>
             </a:ln>
           </p:spPr>
@@ -3933,9 +3796,10 @@
           </a:prstGeom>
           <a:ln w="19050">
             <a:solidFill>
-              <a:srgbClr val="4472C4"/>
+              <a:srgbClr val="C0392B"/>
             </a:solidFill>
             <a:tailEnd type="triangle" w="lg" len="lg"/>
+            <a:prstDash val="dash"/>
           </a:ln>
         </p:spPr>
         <p:style>
@@ -3971,9 +3835,10 @@
           </a:prstGeom>
           <a:ln w="19050">
             <a:solidFill>
-              <a:srgbClr val="4472C4"/>
+              <a:srgbClr val="2E86C1"/>
             </a:solidFill>
             <a:tailEnd type="triangle" w="lg" len="lg"/>
+            <a:prstDash val="dash"/>
           </a:ln>
         </p:spPr>
         <p:style>
@@ -4009,9 +3874,10 @@
           </a:prstGeom>
           <a:ln w="19050">
             <a:solidFill>
-              <a:srgbClr val="4472C4"/>
+              <a:srgbClr val="27AE60"/>
             </a:solidFill>
             <a:tailEnd type="triangle" w="lg" len="lg"/>
+            <a:prstDash val="dash"/>
           </a:ln>
         </p:spPr>
         <p:style>

</xml_diff>